<commit_message>
updates to report, fixed splits
</commit_message>
<xml_diff>
--- a/Group 3 Seizures Deep Learning Presentation.pptx
+++ b/Group 3 Seizures Deep Learning Presentation.pptx
@@ -5,7 +5,7 @@
     <p:sldMasterId id="2147483756" r:id="rId1"/>
   </p:sldMasterIdLst>
   <p:notesMasterIdLst>
-    <p:notesMasterId r:id="rId16"/>
+    <p:notesMasterId r:id="rId17"/>
   </p:notesMasterIdLst>
   <p:sldIdLst>
     <p:sldId id="256" r:id="rId2"/>
@@ -14,14 +14,15 @@
     <p:sldId id="263" r:id="rId5"/>
     <p:sldId id="277" r:id="rId6"/>
     <p:sldId id="298" r:id="rId7"/>
-    <p:sldId id="278" r:id="rId8"/>
-    <p:sldId id="305" r:id="rId9"/>
-    <p:sldId id="303" r:id="rId10"/>
-    <p:sldId id="285" r:id="rId11"/>
-    <p:sldId id="307" r:id="rId12"/>
-    <p:sldId id="306" r:id="rId13"/>
-    <p:sldId id="288" r:id="rId14"/>
-    <p:sldId id="275" r:id="rId15"/>
+    <p:sldId id="308" r:id="rId8"/>
+    <p:sldId id="278" r:id="rId9"/>
+    <p:sldId id="305" r:id="rId10"/>
+    <p:sldId id="303" r:id="rId11"/>
+    <p:sldId id="285" r:id="rId12"/>
+    <p:sldId id="307" r:id="rId13"/>
+    <p:sldId id="306" r:id="rId14"/>
+    <p:sldId id="288" r:id="rId15"/>
+    <p:sldId id="275" r:id="rId16"/>
   </p:sldIdLst>
   <p:sldSz cx="12192000" cy="6858000"/>
   <p:notesSz cx="6858000" cy="9144000"/>
@@ -927,7 +928,7 @@
           <a:p>
             <a:fld id="{4A3C5CF5-2F08-B740-9061-51D0631E3765}" type="datetimeFigureOut">
               <a:rPr lang="en-US" smtClean="0"/>
-              <a:t>3/24/26</a:t>
+              <a:t>4/24/26</a:t>
             </a:fld>
             <a:endParaRPr lang="en-US"/>
           </a:p>
@@ -1529,7 +1530,7 @@
           <a:p>
             <a:fld id="{BD0EE75B-EF0F-E245-A34A-06675D448390}" type="slidenum">
               <a:rPr lang="en-US" smtClean="0"/>
-              <a:t>10</a:t>
+              <a:t>11</a:t>
             </a:fld>
             <a:endParaRPr lang="en-US"/>
           </a:p>
@@ -1637,7 +1638,7 @@
           <a:p>
             <a:fld id="{BD0EE75B-EF0F-E245-A34A-06675D448390}" type="slidenum">
               <a:rPr lang="en-US" smtClean="0"/>
-              <a:t>11</a:t>
+              <a:t>12</a:t>
             </a:fld>
             <a:endParaRPr lang="en-US"/>
           </a:p>
@@ -1776,7 +1777,7 @@
           <a:p>
             <a:fld id="{BD0EE75B-EF0F-E245-A34A-06675D448390}" type="slidenum">
               <a:rPr lang="en-US" smtClean="0"/>
-              <a:t>12</a:t>
+              <a:t>13</a:t>
             </a:fld>
             <a:endParaRPr lang="en-US"/>
           </a:p>
@@ -1902,7 +1903,7 @@
           <a:p>
             <a:fld id="{BD0EE75B-EF0F-E245-A34A-06675D448390}" type="slidenum">
               <a:rPr lang="en-US" smtClean="0"/>
-              <a:t>13</a:t>
+              <a:t>14</a:t>
             </a:fld>
             <a:endParaRPr lang="en-US"/>
           </a:p>
@@ -2068,7 +2069,7 @@
           <a:p>
             <a:fld id="{947FBD62-AA3B-E74B-8A60-7E8626BB6760}" type="datetimeFigureOut">
               <a:rPr lang="en-US" smtClean="0"/>
-              <a:t>3/24/26</a:t>
+              <a:t>4/24/26</a:t>
             </a:fld>
             <a:endParaRPr lang="en-US"/>
           </a:p>
@@ -2266,7 +2267,7 @@
           <a:p>
             <a:fld id="{947FBD62-AA3B-E74B-8A60-7E8626BB6760}" type="datetimeFigureOut">
               <a:rPr lang="en-US" smtClean="0"/>
-              <a:t>3/24/26</a:t>
+              <a:t>4/24/26</a:t>
             </a:fld>
             <a:endParaRPr lang="en-US"/>
           </a:p>
@@ -2474,7 +2475,7 @@
           <a:p>
             <a:fld id="{947FBD62-AA3B-E74B-8A60-7E8626BB6760}" type="datetimeFigureOut">
               <a:rPr lang="en-US" smtClean="0"/>
-              <a:t>3/24/26</a:t>
+              <a:t>4/24/26</a:t>
             </a:fld>
             <a:endParaRPr lang="en-US"/>
           </a:p>
@@ -2672,7 +2673,7 @@
           <a:p>
             <a:fld id="{947FBD62-AA3B-E74B-8A60-7E8626BB6760}" type="datetimeFigureOut">
               <a:rPr lang="en-US" smtClean="0"/>
-              <a:t>3/24/26</a:t>
+              <a:t>4/24/26</a:t>
             </a:fld>
             <a:endParaRPr lang="en-US"/>
           </a:p>
@@ -2947,7 +2948,7 @@
           <a:p>
             <a:fld id="{947FBD62-AA3B-E74B-8A60-7E8626BB6760}" type="datetimeFigureOut">
               <a:rPr lang="en-US" smtClean="0"/>
-              <a:t>3/24/26</a:t>
+              <a:t>4/24/26</a:t>
             </a:fld>
             <a:endParaRPr lang="en-US"/>
           </a:p>
@@ -3212,7 +3213,7 @@
           <a:p>
             <a:fld id="{947FBD62-AA3B-E74B-8A60-7E8626BB6760}" type="datetimeFigureOut">
               <a:rPr lang="en-US" smtClean="0"/>
-              <a:t>3/24/26</a:t>
+              <a:t>4/24/26</a:t>
             </a:fld>
             <a:endParaRPr lang="en-US"/>
           </a:p>
@@ -3624,7 +3625,7 @@
           <a:p>
             <a:fld id="{947FBD62-AA3B-E74B-8A60-7E8626BB6760}" type="datetimeFigureOut">
               <a:rPr lang="en-US" smtClean="0"/>
-              <a:t>3/24/26</a:t>
+              <a:t>4/24/26</a:t>
             </a:fld>
             <a:endParaRPr lang="en-US"/>
           </a:p>
@@ -3765,7 +3766,7 @@
           <a:p>
             <a:fld id="{947FBD62-AA3B-E74B-8A60-7E8626BB6760}" type="datetimeFigureOut">
               <a:rPr lang="en-US" smtClean="0"/>
-              <a:t>3/24/26</a:t>
+              <a:t>4/24/26</a:t>
             </a:fld>
             <a:endParaRPr lang="en-US"/>
           </a:p>
@@ -3878,7 +3879,7 @@
           <a:p>
             <a:fld id="{947FBD62-AA3B-E74B-8A60-7E8626BB6760}" type="datetimeFigureOut">
               <a:rPr lang="en-US" smtClean="0"/>
-              <a:t>3/24/26</a:t>
+              <a:t>4/24/26</a:t>
             </a:fld>
             <a:endParaRPr lang="en-US"/>
           </a:p>
@@ -4189,7 +4190,7 @@
           <a:p>
             <a:fld id="{947FBD62-AA3B-E74B-8A60-7E8626BB6760}" type="datetimeFigureOut">
               <a:rPr lang="en-US" smtClean="0"/>
-              <a:t>3/24/26</a:t>
+              <a:t>4/24/26</a:t>
             </a:fld>
             <a:endParaRPr lang="en-US"/>
           </a:p>
@@ -4477,7 +4478,7 @@
           <a:p>
             <a:fld id="{947FBD62-AA3B-E74B-8A60-7E8626BB6760}" type="datetimeFigureOut">
               <a:rPr lang="en-US" smtClean="0"/>
-              <a:t>3/24/26</a:t>
+              <a:t>4/24/26</a:t>
             </a:fld>
             <a:endParaRPr lang="en-US"/>
           </a:p>
@@ -4718,7 +4719,7 @@
           <a:p>
             <a:fld id="{947FBD62-AA3B-E74B-8A60-7E8626BB6760}" type="datetimeFigureOut">
               <a:rPr lang="en-US" smtClean="0"/>
-              <a:t>3/24/26</a:t>
+              <a:t>4/24/26</a:t>
             </a:fld>
             <a:endParaRPr lang="en-US"/>
           </a:p>
@@ -5302,6 +5303,145 @@
 </file>
 
 <file path=ppt/slides/slide10.xml><?xml version="1.0" encoding="utf-8"?>
+<p:sld xmlns:a="http://schemas.openxmlformats.org/drawingml/2006/main" xmlns:r="http://schemas.openxmlformats.org/officeDocument/2006/relationships" xmlns:p="http://schemas.openxmlformats.org/presentationml/2006/main">
+  <p:cSld>
+    <p:bg>
+      <p:bgPr>
+        <a:solidFill>
+          <a:schemeClr val="bg1"/>
+        </a:solidFill>
+        <a:effectLst/>
+      </p:bgPr>
+    </p:bg>
+    <p:spTree>
+      <p:nvGrpSpPr>
+        <p:cNvPr id="1" name="">
+          <a:extLst>
+            <a:ext uri="{FF2B5EF4-FFF2-40B4-BE49-F238E27FC236}">
+              <a16:creationId xmlns:a16="http://schemas.microsoft.com/office/drawing/2014/main" id="{5351E7BC-B0F2-C3A8-63E2-FBCF0434360E}"/>
+            </a:ext>
+          </a:extLst>
+        </p:cNvPr>
+        <p:cNvGrpSpPr/>
+        <p:nvPr/>
+      </p:nvGrpSpPr>
+      <p:grpSpPr>
+        <a:xfrm>
+          <a:off x="0" y="0"/>
+          <a:ext cx="0" cy="0"/>
+          <a:chOff x="0" y="0"/>
+          <a:chExt cx="0" cy="0"/>
+        </a:xfrm>
+      </p:grpSpPr>
+      <p:pic>
+        <p:nvPicPr>
+          <p:cNvPr id="3" name="Picture 2" descr="A graph of a person and person&#10;&#10;AI-generated content may be incorrect.">
+            <a:extLst>
+              <a:ext uri="{FF2B5EF4-FFF2-40B4-BE49-F238E27FC236}">
+                <a16:creationId xmlns:a16="http://schemas.microsoft.com/office/drawing/2014/main" id="{12963C76-D579-ED1C-E29D-CA93EDF485E0}"/>
+              </a:ext>
+            </a:extLst>
+          </p:cNvPr>
+          <p:cNvPicPr>
+            <a:picLocks noChangeAspect="1"/>
+          </p:cNvPicPr>
+          <p:nvPr/>
+        </p:nvPicPr>
+        <p:blipFill>
+          <a:blip r:embed="rId2"/>
+          <a:stretch>
+            <a:fillRect/>
+          </a:stretch>
+        </p:blipFill>
+        <p:spPr>
+          <a:xfrm>
+            <a:off x="295044" y="698141"/>
+            <a:ext cx="7394823" cy="2982913"/>
+          </a:xfrm>
+          <a:prstGeom prst="rect">
+            <a:avLst/>
+          </a:prstGeom>
+        </p:spPr>
+      </p:pic>
+      <p:pic>
+        <p:nvPicPr>
+          <p:cNvPr id="4" name="Picture 3" descr="A screenshot of a graph&#10;&#10;AI-generated content may be incorrect.">
+            <a:extLst>
+              <a:ext uri="{FF2B5EF4-FFF2-40B4-BE49-F238E27FC236}">
+                <a16:creationId xmlns:a16="http://schemas.microsoft.com/office/drawing/2014/main" id="{B5A393D9-3AE4-E496-CA9F-E0A5A8BA966C}"/>
+              </a:ext>
+            </a:extLst>
+          </p:cNvPr>
+          <p:cNvPicPr>
+            <a:picLocks noChangeAspect="1"/>
+          </p:cNvPicPr>
+          <p:nvPr/>
+        </p:nvPicPr>
+        <p:blipFill>
+          <a:blip r:embed="rId3"/>
+          <a:stretch>
+            <a:fillRect/>
+          </a:stretch>
+        </p:blipFill>
+        <p:spPr>
+          <a:xfrm>
+            <a:off x="4762933" y="3429000"/>
+            <a:ext cx="7262812" cy="3304306"/>
+          </a:xfrm>
+          <a:prstGeom prst="rect">
+            <a:avLst/>
+          </a:prstGeom>
+        </p:spPr>
+      </p:pic>
+      <p:sp>
+        <p:nvSpPr>
+          <p:cNvPr id="2" name="Title 1">
+            <a:extLst>
+              <a:ext uri="{FF2B5EF4-FFF2-40B4-BE49-F238E27FC236}">
+                <a16:creationId xmlns:a16="http://schemas.microsoft.com/office/drawing/2014/main" id="{7DD79E17-236A-6E63-F8FF-C80AD64F69E0}"/>
+              </a:ext>
+            </a:extLst>
+          </p:cNvPr>
+          <p:cNvSpPr>
+            <a:spLocks noGrp="1"/>
+          </p:cNvSpPr>
+          <p:nvPr>
+            <p:ph type="title"/>
+          </p:nvPr>
+        </p:nvSpPr>
+        <p:spPr>
+          <a:xfrm>
+            <a:off x="145415" y="-157162"/>
+            <a:ext cx="10515600" cy="1325563"/>
+          </a:xfrm>
+        </p:spPr>
+        <p:txBody>
+          <a:bodyPr>
+            <a:normAutofit/>
+          </a:bodyPr>
+          <a:lstStyle/>
+          <a:p>
+            <a:r>
+              <a:rPr lang="en-US" sz="4000" dirty="0"/>
+              <a:t>Results: Understanding Training Process</a:t>
+            </a:r>
+          </a:p>
+        </p:txBody>
+      </p:sp>
+    </p:spTree>
+    <p:extLst>
+      <p:ext uri="{BB962C8B-B14F-4D97-AF65-F5344CB8AC3E}">
+        <p14:creationId xmlns:p14="http://schemas.microsoft.com/office/powerpoint/2010/main" val="786601153"/>
+      </p:ext>
+    </p:extLst>
+  </p:cSld>
+  <p:clrMapOvr>
+    <a:masterClrMapping/>
+  </p:clrMapOvr>
+</p:sld>
+</file>
+
+<file path=ppt/slides/slide11.xml><?xml version="1.0" encoding="utf-8"?>
 <p:sld xmlns:a="http://schemas.openxmlformats.org/drawingml/2006/main" xmlns:r="http://schemas.openxmlformats.org/officeDocument/2006/relationships" xmlns:p="http://schemas.openxmlformats.org/presentationml/2006/main" show="0">
   <p:cSld>
     <p:bg>
@@ -5402,7 +5542,7 @@
 </p:sld>
 </file>
 
-<file path=ppt/slides/slide11.xml><?xml version="1.0" encoding="utf-8"?>
+<file path=ppt/slides/slide12.xml><?xml version="1.0" encoding="utf-8"?>
 <p:sld xmlns:a="http://schemas.openxmlformats.org/drawingml/2006/main" xmlns:r="http://schemas.openxmlformats.org/officeDocument/2006/relationships" xmlns:p="http://schemas.openxmlformats.org/presentationml/2006/main">
   <p:cSld>
     <p:bg>
@@ -5730,7 +5870,7 @@
 </p:sld>
 </file>
 
-<file path=ppt/slides/slide12.xml><?xml version="1.0" encoding="utf-8"?>
+<file path=ppt/slides/slide13.xml><?xml version="1.0" encoding="utf-8"?>
 <p:sld xmlns:a="http://schemas.openxmlformats.org/drawingml/2006/main" xmlns:r="http://schemas.openxmlformats.org/officeDocument/2006/relationships" xmlns:p="http://schemas.openxmlformats.org/presentationml/2006/main" show="0">
   <p:cSld>
     <p:bg>
@@ -5837,7 +5977,7 @@
 </p:sld>
 </file>
 
-<file path=ppt/slides/slide13.xml><?xml version="1.0" encoding="utf-8"?>
+<file path=ppt/slides/slide14.xml><?xml version="1.0" encoding="utf-8"?>
 <p:sld xmlns:a="http://schemas.openxmlformats.org/drawingml/2006/main" xmlns:r="http://schemas.openxmlformats.org/officeDocument/2006/relationships" xmlns:p="http://schemas.openxmlformats.org/presentationml/2006/main">
   <p:cSld>
     <p:bg>
@@ -5944,7 +6084,7 @@
 </p:sld>
 </file>
 
-<file path=ppt/slides/slide14.xml><?xml version="1.0" encoding="utf-8"?>
+<file path=ppt/slides/slide15.xml><?xml version="1.0" encoding="utf-8"?>
 <p:sld xmlns:a="http://schemas.openxmlformats.org/drawingml/2006/main" xmlns:r="http://schemas.openxmlformats.org/officeDocument/2006/relationships" xmlns:p="http://schemas.openxmlformats.org/presentationml/2006/main">
   <p:cSld>
     <p:bg>
@@ -7729,7 +7869,7 @@
 </file>
 
 <file path=ppt/slides/slide5.xml><?xml version="1.0" encoding="utf-8"?>
-<p:sld xmlns:a="http://schemas.openxmlformats.org/drawingml/2006/main" xmlns:r="http://schemas.openxmlformats.org/officeDocument/2006/relationships" xmlns:p="http://schemas.openxmlformats.org/presentationml/2006/main">
+<p:sld xmlns:a="http://schemas.openxmlformats.org/drawingml/2006/main" xmlns:r="http://schemas.openxmlformats.org/officeDocument/2006/relationships" xmlns:p="http://schemas.openxmlformats.org/presentationml/2006/main" show="0">
   <p:cSld>
     <p:bg>
       <p:bgPr>
@@ -8002,7 +8142,7 @@
           <a:p>
             <a:r>
               <a:rPr lang="en-US" dirty="0"/>
-              <a:t>Methodology Overview</a:t>
+              <a:t>CNN Methodology Overview</a:t>
             </a:r>
           </a:p>
         </p:txBody>
@@ -8097,6 +8237,83 @@
 </file>
 
 <file path=ppt/slides/slide7.xml><?xml version="1.0" encoding="utf-8"?>
+<p:sld xmlns:a="http://schemas.openxmlformats.org/drawingml/2006/main" xmlns:r="http://schemas.openxmlformats.org/officeDocument/2006/relationships" xmlns:p="http://schemas.openxmlformats.org/presentationml/2006/main">
+  <p:cSld>
+    <p:bg>
+      <p:bgPr>
+        <a:solidFill>
+          <a:schemeClr val="accent2"/>
+        </a:solidFill>
+        <a:effectLst/>
+      </p:bgPr>
+    </p:bg>
+    <p:spTree>
+      <p:nvGrpSpPr>
+        <p:cNvPr id="1" name="">
+          <a:extLst>
+            <a:ext uri="{FF2B5EF4-FFF2-40B4-BE49-F238E27FC236}">
+              <a16:creationId xmlns:a16="http://schemas.microsoft.com/office/drawing/2014/main" id="{12D7882F-E38D-55D3-208A-6435749327CE}"/>
+            </a:ext>
+          </a:extLst>
+        </p:cNvPr>
+        <p:cNvGrpSpPr/>
+        <p:nvPr/>
+      </p:nvGrpSpPr>
+      <p:grpSpPr>
+        <a:xfrm>
+          <a:off x="0" y="0"/>
+          <a:ext cx="0" cy="0"/>
+          <a:chOff x="0" y="0"/>
+          <a:chExt cx="0" cy="0"/>
+        </a:xfrm>
+      </p:grpSpPr>
+      <p:sp>
+        <p:nvSpPr>
+          <p:cNvPr id="11" name="Title 1">
+            <a:extLst>
+              <a:ext uri="{FF2B5EF4-FFF2-40B4-BE49-F238E27FC236}">
+                <a16:creationId xmlns:a16="http://schemas.microsoft.com/office/drawing/2014/main" id="{33251C04-4FD7-D89A-3B80-9B50811B8964}"/>
+              </a:ext>
+            </a:extLst>
+          </p:cNvPr>
+          <p:cNvSpPr>
+            <a:spLocks noGrp="1"/>
+          </p:cNvSpPr>
+          <p:nvPr>
+            <p:ph type="title"/>
+          </p:nvPr>
+        </p:nvSpPr>
+        <p:spPr>
+          <a:xfrm>
+            <a:off x="223104" y="0"/>
+            <a:ext cx="10515600" cy="1325563"/>
+          </a:xfrm>
+        </p:spPr>
+        <p:txBody>
+          <a:bodyPr/>
+          <a:lstStyle/>
+          <a:p>
+            <a:r>
+              <a:rPr lang="en-US" dirty="0"/>
+              <a:t>LSTM Methodology Overview</a:t>
+            </a:r>
+          </a:p>
+        </p:txBody>
+      </p:sp>
+    </p:spTree>
+    <p:extLst>
+      <p:ext uri="{BB962C8B-B14F-4D97-AF65-F5344CB8AC3E}">
+        <p14:creationId xmlns:p14="http://schemas.microsoft.com/office/powerpoint/2010/main" val="2077160234"/>
+      </p:ext>
+    </p:extLst>
+  </p:cSld>
+  <p:clrMapOvr>
+    <a:masterClrMapping/>
+  </p:clrMapOvr>
+</p:sld>
+</file>
+
+<file path=ppt/slides/slide8.xml><?xml version="1.0" encoding="utf-8"?>
 <p:sld xmlns:a="http://schemas.openxmlformats.org/drawingml/2006/main" xmlns:r="http://schemas.openxmlformats.org/officeDocument/2006/relationships" xmlns:p="http://schemas.openxmlformats.org/presentationml/2006/main">
   <p:cSld>
     <p:bg>
@@ -8379,7 +8596,7 @@
 </p:sld>
 </file>
 
-<file path=ppt/slides/slide8.xml><?xml version="1.0" encoding="utf-8"?>
+<file path=ppt/slides/slide9.xml><?xml version="1.0" encoding="utf-8"?>
 <p:sld xmlns:a="http://schemas.openxmlformats.org/drawingml/2006/main" xmlns:r="http://schemas.openxmlformats.org/officeDocument/2006/relationships" xmlns:p="http://schemas.openxmlformats.org/presentationml/2006/main">
   <p:cSld>
     <p:bg>
@@ -8644,145 +8861,6 @@
     <p:extLst>
       <p:ext uri="{BB962C8B-B14F-4D97-AF65-F5344CB8AC3E}">
         <p14:creationId xmlns:p14="http://schemas.microsoft.com/office/powerpoint/2010/main" val="3394601628"/>
-      </p:ext>
-    </p:extLst>
-  </p:cSld>
-  <p:clrMapOvr>
-    <a:masterClrMapping/>
-  </p:clrMapOvr>
-</p:sld>
-</file>
-
-<file path=ppt/slides/slide9.xml><?xml version="1.0" encoding="utf-8"?>
-<p:sld xmlns:a="http://schemas.openxmlformats.org/drawingml/2006/main" xmlns:r="http://schemas.openxmlformats.org/officeDocument/2006/relationships" xmlns:p="http://schemas.openxmlformats.org/presentationml/2006/main">
-  <p:cSld>
-    <p:bg>
-      <p:bgPr>
-        <a:solidFill>
-          <a:schemeClr val="bg1"/>
-        </a:solidFill>
-        <a:effectLst/>
-      </p:bgPr>
-    </p:bg>
-    <p:spTree>
-      <p:nvGrpSpPr>
-        <p:cNvPr id="1" name="">
-          <a:extLst>
-            <a:ext uri="{FF2B5EF4-FFF2-40B4-BE49-F238E27FC236}">
-              <a16:creationId xmlns:a16="http://schemas.microsoft.com/office/drawing/2014/main" id="{5351E7BC-B0F2-C3A8-63E2-FBCF0434360E}"/>
-            </a:ext>
-          </a:extLst>
-        </p:cNvPr>
-        <p:cNvGrpSpPr/>
-        <p:nvPr/>
-      </p:nvGrpSpPr>
-      <p:grpSpPr>
-        <a:xfrm>
-          <a:off x="0" y="0"/>
-          <a:ext cx="0" cy="0"/>
-          <a:chOff x="0" y="0"/>
-          <a:chExt cx="0" cy="0"/>
-        </a:xfrm>
-      </p:grpSpPr>
-      <p:sp>
-        <p:nvSpPr>
-          <p:cNvPr id="2" name="Title 1">
-            <a:extLst>
-              <a:ext uri="{FF2B5EF4-FFF2-40B4-BE49-F238E27FC236}">
-                <a16:creationId xmlns:a16="http://schemas.microsoft.com/office/drawing/2014/main" id="{7DD79E17-236A-6E63-F8FF-C80AD64F69E0}"/>
-              </a:ext>
-            </a:extLst>
-          </p:cNvPr>
-          <p:cNvSpPr>
-            <a:spLocks noGrp="1"/>
-          </p:cNvSpPr>
-          <p:nvPr>
-            <p:ph type="title"/>
-          </p:nvPr>
-        </p:nvSpPr>
-        <p:spPr>
-          <a:xfrm>
-            <a:off x="145415" y="-157162"/>
-            <a:ext cx="10515600" cy="1325563"/>
-          </a:xfrm>
-        </p:spPr>
-        <p:txBody>
-          <a:bodyPr>
-            <a:normAutofit/>
-          </a:bodyPr>
-          <a:lstStyle/>
-          <a:p>
-            <a:r>
-              <a:rPr lang="en-US" sz="4000" dirty="0"/>
-              <a:t>Results: Understanding Training Process</a:t>
-            </a:r>
-          </a:p>
-        </p:txBody>
-      </p:sp>
-      <p:pic>
-        <p:nvPicPr>
-          <p:cNvPr id="3" name="Picture 2" descr="A graph of a person and person&#10;&#10;AI-generated content may be incorrect.">
-            <a:extLst>
-              <a:ext uri="{FF2B5EF4-FFF2-40B4-BE49-F238E27FC236}">
-                <a16:creationId xmlns:a16="http://schemas.microsoft.com/office/drawing/2014/main" id="{12963C76-D579-ED1C-E29D-CA93EDF485E0}"/>
-              </a:ext>
-            </a:extLst>
-          </p:cNvPr>
-          <p:cNvPicPr>
-            <a:picLocks noChangeAspect="1"/>
-          </p:cNvPicPr>
-          <p:nvPr/>
-        </p:nvPicPr>
-        <p:blipFill>
-          <a:blip r:embed="rId2"/>
-          <a:stretch>
-            <a:fillRect/>
-          </a:stretch>
-        </p:blipFill>
-        <p:spPr>
-          <a:xfrm>
-            <a:off x="145415" y="698141"/>
-            <a:ext cx="7394823" cy="2982913"/>
-          </a:xfrm>
-          <a:prstGeom prst="rect">
-            <a:avLst/>
-          </a:prstGeom>
-        </p:spPr>
-      </p:pic>
-      <p:pic>
-        <p:nvPicPr>
-          <p:cNvPr id="4" name="Picture 3" descr="A screenshot of a graph&#10;&#10;AI-generated content may be incorrect.">
-            <a:extLst>
-              <a:ext uri="{FF2B5EF4-FFF2-40B4-BE49-F238E27FC236}">
-                <a16:creationId xmlns:a16="http://schemas.microsoft.com/office/drawing/2014/main" id="{B5A393D9-3AE4-E496-CA9F-E0A5A8BA966C}"/>
-              </a:ext>
-            </a:extLst>
-          </p:cNvPr>
-          <p:cNvPicPr>
-            <a:picLocks noChangeAspect="1"/>
-          </p:cNvPicPr>
-          <p:nvPr/>
-        </p:nvPicPr>
-        <p:blipFill>
-          <a:blip r:embed="rId3"/>
-          <a:stretch>
-            <a:fillRect/>
-          </a:stretch>
-        </p:blipFill>
-        <p:spPr>
-          <a:xfrm>
-            <a:off x="4057139" y="3553694"/>
-            <a:ext cx="7262812" cy="3304306"/>
-          </a:xfrm>
-          <a:prstGeom prst="rect">
-            <a:avLst/>
-          </a:prstGeom>
-        </p:spPr>
-      </p:pic>
-    </p:spTree>
-    <p:extLst>
-      <p:ext uri="{BB962C8B-B14F-4D97-AF65-F5344CB8AC3E}">
-        <p14:creationId xmlns:p14="http://schemas.microsoft.com/office/powerpoint/2010/main" val="786601153"/>
       </p:ext>
     </p:extLst>
   </p:cSld>

</xml_diff>